<commit_message>
Présentation : corrections de texte (annexes 3, 4, 6, 8, 9 et résultats) ; schéma en étoile : cardinalités zéro ou plusieurs côté faits
</commit_message>
<xml_diff>
--- a/2_Stripe_Business_Case/01_presentation/Presentation_Stripe.pptx
+++ b/2_Stripe_Business_Case/01_presentation/Presentation_Stripe.pptx
@@ -3670,7 +3670,7 @@
                   <a:schemeClr val="tx2"/>
                 </a:solidFill>
               </a:rPr>
-              <a:t>Annexe 3 - Schéma en étoile de l’entrepôt analytique </a:t>
+              <a:t>Annexe 3 - Schéma en étoile de l'entrepôt analytique </a:t>
             </a:r>
             <a:r>
               <a:rPr lang="fr-FR" sz="1200" dirty="0"/>
@@ -3856,7 +3856,7 @@
             </a:r>
             <a:r>
               <a:rPr lang="fr-FR" sz="1200" dirty="0"/>
-              <a:t>le carnet en vrac )</a:t>
+              <a:t>le carnet en vrac)</a:t>
             </a:r>
             <a:endParaRPr lang="en-US" sz="1200" dirty="0"/>
           </a:p>
@@ -4211,7 +4211,7 @@
             </a:r>
             <a:r>
               <a:rPr lang="fr-FR" sz="1200" dirty="0"/>
-              <a:t>L’intégration de l'intelligence artificielle)</a:t>
+              <a:t>intégration de l'intelligence artificielle)</a:t>
             </a:r>
             <a:endParaRPr lang="en-US" sz="1200" dirty="0"/>
           </a:p>
@@ -4973,7 +4973,7 @@
                           <a:ea typeface="Calibri" pitchFamily="34" charset="-122"/>
                           <a:cs typeface="Calibri" pitchFamily="34" charset="-120"/>
                         </a:rPr>
-                        <a:t>MySQL : décodage logique et partitionnement moins complets ; SQL distribué réservé à la cible</a:t>
+                        <a:t>MySQL : possible ; PostgreSQL retenu pour pgcrypto, les types INET et JSONB, les index partiels et la synchronisation de la capture sur le réplica</a:t>
                       </a:r>
                       <a:endParaRPr lang="en-US" sz="1400" dirty="0">
                         <a:latin typeface="Calibri" charset="0"/>
@@ -5817,7 +5817,7 @@
                           <a:ea typeface="Calibri" pitchFamily="34" charset="-122"/>
                           <a:cs typeface="Calibri" pitchFamily="34" charset="-120"/>
                         </a:rPr>
-                        <a:t>RabbitMQ : pas de relecture d'historique ni d'ordre par clé à grande échelle</a:t>
+                        <a:t>RabbitMQ : relecture possible avec ses streams, mais Debezium s'exécute nativement sur Kafka Connect</a:t>
                       </a:r>
                       <a:endParaRPr lang="en-US" sz="1400" dirty="0">
                         <a:latin typeface="Calibri" charset="0"/>
@@ -7807,7 +7807,7 @@
                           <a:ea typeface="Calibri" pitchFamily="34" charset="-122"/>
                           <a:cs typeface="Calibri" pitchFamily="34" charset="-120"/>
                         </a:rPr>
-                        <a:t>Réécriture à partir de la caisse</a:t>
+                        <a:t>Réécriture à partir de la base transactionnelle</a:t>
                       </a:r>
                       <a:endParaRPr lang="en-US" sz="1400" dirty="0">
                         <a:latin typeface="Calibri" charset="0"/>
@@ -20711,7 +20711,7 @@
                 <a:ea typeface="Calibri" pitchFamily="34" charset="-122"/>
                 <a:cs typeface="Calibri" pitchFamily="34" charset="-120"/>
               </a:rPr>
-              <a:t>suivi par son identifiant commun : caisse, NoSQL, entrepôt</a:t>
+              <a:t>suivi par son identifiant commun : base transactionnelle, NoSQL, entrepôt</a:t>
             </a:r>
             <a:endParaRPr lang="en-US" sz="1400" dirty="0"/>
           </a:p>

</xml_diff>